<commit_message>
modificaciones en informe y presentacion
</commit_message>
<xml_diff>
--- a/Presentacion_Examen_Final.pptx
+++ b/Presentacion_Examen_Final.pptx
@@ -4,6 +4,9 @@
   <p:sldMasterIdLst>
     <p:sldMasterId id="2147483648" r:id="rId1"/>
   </p:sldMasterIdLst>
+  <p:notesMasterIdLst>
+    <p:notesMasterId r:id="rId13"/>
+  </p:notesMasterIdLst>
   <p:sldIdLst>
     <p:sldId id="256" r:id="rId2"/>
     <p:sldId id="257" r:id="rId3"/>
@@ -17,9 +20,6 @@
     <p:sldId id="265" r:id="rId11"/>
     <p:sldId id="266" r:id="rId12"/>
   </p:sldIdLst>
-  <p:notesMasterIdLst>
-    <p:notesMasterId r:id="rId13"/>
-  </p:notesMasterIdLst>
   <p:sldSz cx="12192000" cy="6858000"/>
   <p:notesSz cx="6858000" cy="12192000"/>
   <p:defaultTextStyle>
@@ -114,13 +114,20 @@
       </a:defRPr>
     </a:lvl9pPr>
   </p:defaultTextStyle>
+  <p:extLst>
+    <p:ext uri="{EFAFB233-063F-42B5-8137-9DF3F51BA10A}">
+      <p15:sldGuideLst xmlns:p15="http://schemas.microsoft.com/office/powerpoint/2012/main"/>
+    </p:ext>
+  </p:extLst>
 </p:presentation>
 </file>
 
 <file path=ppt/charts/chart1.xml><?xml version="1.0" encoding="utf-8"?>
-<c:chartSpace xmlns:c="http://schemas.openxmlformats.org/drawingml/2006/chart" xmlns:a="http://schemas.openxmlformats.org/drawingml/2006/main" xmlns:r="http://schemas.openxmlformats.org/officeDocument/2006/relationships">
+<c:chartSpace xmlns:c="http://schemas.openxmlformats.org/drawingml/2006/chart" xmlns:a="http://schemas.openxmlformats.org/drawingml/2006/main" xmlns:r="http://schemas.openxmlformats.org/officeDocument/2006/relationships" xmlns:c16r2="http://schemas.microsoft.com/office/drawing/2015/06/chart">
   <c:date1904 val="0"/>
+  <c:lang val="es-ES"/>
   <c:roundedCorners val="1"/>
+  <c:style val="2"/>
   <c:chart>
     <c:title>
       <c:tx>
@@ -148,7 +155,6 @@
           </a:p>
         </c:rich>
       </c:tx>
-      <c:layout/>
       <c:overlay val="0"/>
     </c:title>
     <c:autoTitleDeleted val="0"/>
@@ -179,84 +185,55 @@
             <a:effectLst/>
           </c:spPr>
           <c:invertIfNegative val="0"/>
-          <c:dLbls>
-            <c:numFmt formatCode="#,##0" sourceLinked="0"/>
-            <c:txPr>
-              <a:bodyPr/>
-              <a:lstStyle/>
-              <a:p>
-                <a:pPr>
-                  <a:defRPr b="0" i="0" strike="noStrike" sz="1200" u="none">
-                    <a:solidFill>
-                      <a:srgbClr val="000000"/>
-                    </a:solidFill>
-                    <a:latin typeface="Arial"/>
-                  </a:defRPr>
-                </a:pPr>
-              </a:p>
-            </c:txPr>
-            <c:showLegendKey val="0"/>
-            <c:showVal val="0"/>
-            <c:showCatName val="0"/>
-            <c:showSerName val="0"/>
-            <c:showPercent val="0"/>
-            <c:showBubbleSize val="0"/>
-            <c:showLeaderLines val="0"/>
-          </c:dLbls>
           <c:dPt>
             <c:idx val="0"/>
             <c:invertIfNegative val="0"/>
             <c:bubble3D val="0"/>
-            <c:spPr>
-              <a:solidFill>
-                <a:srgbClr val="13A89E"/>
-              </a:solidFill>
-              <a:effectLst/>
-            </c:spPr>
+            <c:extLst>
+              <c:ext xmlns:c16="http://schemas.microsoft.com/office/drawing/2014/chart" uri="{C3380CC4-5D6E-409C-BE32-E72D297353CC}">
+                <c16:uniqueId val="{00000001-0B85-416E-AEBE-59D54F36602C}"/>
+              </c:ext>
+            </c:extLst>
           </c:dPt>
           <c:dPt>
             <c:idx val="1"/>
             <c:invertIfNegative val="0"/>
             <c:bubble3D val="0"/>
-            <c:spPr>
-              <a:solidFill>
-                <a:srgbClr val="13A89E"/>
-              </a:solidFill>
-              <a:effectLst/>
-            </c:spPr>
+            <c:extLst>
+              <c:ext xmlns:c16="http://schemas.microsoft.com/office/drawing/2014/chart" uri="{C3380CC4-5D6E-409C-BE32-E72D297353CC}">
+                <c16:uniqueId val="{00000003-0B85-416E-AEBE-59D54F36602C}"/>
+              </c:ext>
+            </c:extLst>
           </c:dPt>
           <c:dPt>
             <c:idx val="2"/>
             <c:invertIfNegative val="0"/>
             <c:bubble3D val="0"/>
-            <c:spPr>
-              <a:solidFill>
-                <a:srgbClr val="13A89E"/>
-              </a:solidFill>
-              <a:effectLst/>
-            </c:spPr>
+            <c:extLst>
+              <c:ext xmlns:c16="http://schemas.microsoft.com/office/drawing/2014/chart" uri="{C3380CC4-5D6E-409C-BE32-E72D297353CC}">
+                <c16:uniqueId val="{00000005-0B85-416E-AEBE-59D54F36602C}"/>
+              </c:ext>
+            </c:extLst>
           </c:dPt>
           <c:dPt>
             <c:idx val="3"/>
             <c:invertIfNegative val="0"/>
             <c:bubble3D val="0"/>
-            <c:spPr>
-              <a:solidFill>
-                <a:srgbClr val="13A89E"/>
-              </a:solidFill>
-              <a:effectLst/>
-            </c:spPr>
+            <c:extLst>
+              <c:ext xmlns:c16="http://schemas.microsoft.com/office/drawing/2014/chart" uri="{C3380CC4-5D6E-409C-BE32-E72D297353CC}">
+                <c16:uniqueId val="{00000007-0B85-416E-AEBE-59D54F36602C}"/>
+              </c:ext>
+            </c:extLst>
           </c:dPt>
           <c:dPt>
             <c:idx val="4"/>
             <c:invertIfNegative val="0"/>
             <c:bubble3D val="0"/>
-            <c:spPr>
-              <a:solidFill>
-                <a:srgbClr val="13A89E"/>
-              </a:solidFill>
-              <a:effectLst/>
-            </c:spPr>
+            <c:extLst>
+              <c:ext xmlns:c16="http://schemas.microsoft.com/office/drawing/2014/chart" uri="{C3380CC4-5D6E-409C-BE32-E72D297353CC}">
+                <c16:uniqueId val="{00000009-0B85-416E-AEBE-59D54F36602C}"/>
+              </c:ext>
+            </c:extLst>
           </c:dPt>
           <c:dPt>
             <c:idx val="5"/>
@@ -268,34 +245,37 @@
               </a:solidFill>
               <a:effectLst/>
             </c:spPr>
+            <c:extLst>
+              <c:ext xmlns:c16="http://schemas.microsoft.com/office/drawing/2014/chart" uri="{C3380CC4-5D6E-409C-BE32-E72D297353CC}">
+                <c16:uniqueId val="{0000000B-0B85-416E-AEBE-59D54F36602C}"/>
+              </c:ext>
+            </c:extLst>
           </c:dPt>
           <c:cat>
-            <c:multiLvlStrRef>
+            <c:strRef>
               <c:f>Sheet1!$A$2:$A$7</c:f>
-              <c:multiLvlStrCache>
+              <c:strCache>
                 <c:ptCount val="6"/>
-                <c:lvl>
-                  <c:pt idx="0">
-                    <c:v>monthly_charge</c:v>
-                  </c:pt>
-                  <c:pt idx="1">
-                    <c:v>tenure_months</c:v>
-                  </c:pt>
-                  <c:pt idx="2">
-                    <c:v>late_payments</c:v>
-                  </c:pt>
-                  <c:pt idx="3">
-                    <c:v>total_charges</c:v>
-                  </c:pt>
-                  <c:pt idx="4">
-                    <c:v>internet_service</c:v>
-                  </c:pt>
-                  <c:pt idx="5">
-                    <c:v>resto (10 cols)</c:v>
-                  </c:pt>
-                </c:lvl>
-              </c:multiLvlStrCache>
-            </c:multiLvlStrRef>
+                <c:pt idx="0">
+                  <c:v>monthly_charge</c:v>
+                </c:pt>
+                <c:pt idx="1">
+                  <c:v>tenure_months</c:v>
+                </c:pt>
+                <c:pt idx="2">
+                  <c:v>late_payments</c:v>
+                </c:pt>
+                <c:pt idx="3">
+                  <c:v>total_charges</c:v>
+                </c:pt>
+                <c:pt idx="4">
+                  <c:v>internet_service</c:v>
+                </c:pt>
+                <c:pt idx="5">
+                  <c:v>resto (10 cols)</c:v>
+                </c:pt>
+              </c:strCache>
+            </c:strRef>
           </c:cat>
           <c:val>
             <c:numRef>
@@ -324,36 +304,23 @@
               </c:numCache>
             </c:numRef>
           </c:val>
+          <c:extLst>
+            <c:ext xmlns:c16="http://schemas.microsoft.com/office/drawing/2014/chart" uri="{C3380CC4-5D6E-409C-BE32-E72D297353CC}">
+              <c16:uniqueId val="{0000000C-0B85-416E-AEBE-59D54F36602C}"/>
+            </c:ext>
+          </c:extLst>
         </c:ser>
         <c:dLbls>
-          <c:numFmt formatCode="#,##0" sourceLinked="0"/>
-          <c:txPr>
-            <a:bodyPr/>
-            <a:lstStyle/>
-            <a:p>
-              <a:pPr>
-                <a:defRPr b="0" i="0" strike="noStrike" sz="1200" u="none">
-                  <a:solidFill>
-                    <a:srgbClr val="000000"/>
-                  </a:solidFill>
-                  <a:latin typeface="Arial"/>
-                </a:defRPr>
-              </a:pPr>
-            </a:p>
-          </c:txPr>
           <c:showLegendKey val="0"/>
           <c:showVal val="0"/>
           <c:showCatName val="0"/>
           <c:showSerName val="0"/>
           <c:showPercent val="0"/>
           <c:showBubbleSize val="0"/>
-          <c:showLeaderLines val="0"/>
         </c:dLbls>
         <c:gapWidth val="150"/>
-        <c:overlap val="0"/>
         <c:axId val="2094734554"/>
         <c:axId val="2094734552"/>
-        <c:axId val="2094734556"/>
       </c:barChart>
       <c:catAx>
         <c:axId val="2094734554"/>
@@ -394,6 +361,7 @@
         <c:crosses val="autoZero"/>
         <c:auto val="1"/>
         <c:lblAlgn val="ctr"/>
+        <c:lblOffset val="100"/>
         <c:noMultiLvlLbl val="1"/>
       </c:catAx>
       <c:valAx>
@@ -407,30 +375,6 @@
         <c:majorTickMark val="out"/>
         <c:minorTickMark val="none"/>
         <c:tickLblPos val="nextTo"/>
-        <c:spPr>
-          <a:ln w="12700" cap="flat">
-            <a:solidFill>
-              <a:srgbClr val="888888"/>
-            </a:solidFill>
-            <a:prstDash val="solid"/>
-            <a:round/>
-          </a:ln>
-        </c:spPr>
-        <c:txPr>
-          <a:bodyPr/>
-          <a:lstStyle/>
-          <a:p>
-            <a:pPr>
-              <a:defRPr sz="1200" b="0" i="0" u="none" strike="noStrike">
-                <a:solidFill>
-                  <a:srgbClr val="13293D"/>
-                </a:solidFill>
-                <a:latin typeface="Arial"/>
-              </a:defRPr>
-            </a:pPr>
-            <a:endParaRPr lang="en-US"/>
-          </a:p>
-        </c:txPr>
         <c:crossAx val="2094734554"/>
         <c:crosses val="autoZero"/>
         <c:crossBetween val="between"/>
@@ -445,6 +389,7 @@
     </c:plotArea>
     <c:plotVisOnly val="1"/>
     <c:dispBlanksAs val="span"/>
+    <c:showDLblsOverMax val="1"/>
   </c:chart>
   <c:spPr>
     <a:noFill/>
@@ -481,234 +426,10 @@
           <a:chExt cx="0" cy="0"/>
         </a:xfrm>
       </p:grpSpPr>
-      <p:sp>
-        <p:nvSpPr>
-          <p:cNvPr id="2" name="Header Placeholder 1"/>
-          <p:cNvSpPr>
-            <a:spLocks noGrp="1"/>
-          </p:cNvSpPr>
-          <p:nvPr>
-            <p:ph type="hdr" sz="quarter"/>
-          </p:nvPr>
-        </p:nvSpPr>
-        <p:spPr>
-          <a:xfrm>
-            <a:off x="0" y="0"/>
-            <a:ext cx="2971800" cy="458788"/>
-          </a:xfrm>
-          <a:prstGeom prst="rect">
-            <a:avLst/>
-          </a:prstGeom>
-        </p:spPr>
-        <p:txBody>
-          <a:bodyPr vert="horz" lIns="91440" tIns="45720" rIns="91440" bIns="45720" rtlCol="0"/>
-          <a:lstStyle>
-            <a:lvl1pPr algn="l">
-              <a:defRPr sz="1200"/>
-            </a:lvl1pPr>
-          </a:lstStyle>
-          <a:p>
-            <a:endParaRPr lang="en-US"/>
-          </a:p>
-        </p:txBody>
-      </p:sp>
-      <p:sp>
-        <p:nvSpPr>
-          <p:cNvPr id="3" name="Date Placeholder 2"/>
-          <p:cNvSpPr>
-            <a:spLocks noGrp="1"/>
-          </p:cNvSpPr>
-          <p:nvPr>
-            <p:ph type="dt" idx="1"/>
-          </p:nvPr>
-        </p:nvSpPr>
-        <p:spPr>
-          <a:xfrm>
-            <a:off x="3884613" y="0"/>
-            <a:ext cx="2971800" cy="458788"/>
-          </a:xfrm>
-          <a:prstGeom prst="rect">
-            <a:avLst/>
-          </a:prstGeom>
-        </p:spPr>
-        <p:txBody>
-          <a:bodyPr vert="horz" lIns="91440" tIns="45720" rIns="91440" bIns="45720" rtlCol="0"/>
-          <a:lstStyle>
-            <a:lvl1pPr algn="r">
-              <a:defRPr sz="1200"/>
-            </a:lvl1pPr>
-          </a:lstStyle>
-          <a:p>
-            <a:fld id="{5282F153-3F37-0F45-9E97-73ACFA13230C}" type="datetimeFigureOut">
-              <a:rPr lang="en-US"/>
-              <a:t>7/23/19</a:t>
-            </a:fld>
-            <a:endParaRPr lang="en-US"/>
-          </a:p>
-        </p:txBody>
-      </p:sp>
-      <p:sp>
-        <p:nvSpPr>
-          <p:cNvPr id="4" name="Slide Image Placeholder 3"/>
-          <p:cNvSpPr>
-            <a:spLocks noGrp="1" noRot="1" noChangeAspect="1"/>
-          </p:cNvSpPr>
-          <p:nvPr>
-            <p:ph type="sldImg" idx="2"/>
-          </p:nvPr>
-        </p:nvSpPr>
-        <p:spPr>
-          <a:xfrm>
-            <a:off x="685800" y="1143000"/>
-            <a:ext cx="5486400" cy="3086100"/>
-          </a:xfrm>
-          <a:prstGeom prst="rect">
-            <a:avLst/>
-          </a:prstGeom>
-          <a:noFill/>
-          <a:ln w="12700">
-            <a:solidFill>
-              <a:prstClr val="black"/>
-            </a:solidFill>
-          </a:ln>
-        </p:spPr>
-        <p:txBody>
-          <a:bodyPr vert="horz" lIns="91440" tIns="45720" rIns="91440" bIns="45720" rtlCol="0" anchor="ctr"/>
-          <a:lstStyle/>
-          <a:p>
-            <a:endParaRPr lang="en-US"/>
-          </a:p>
-        </p:txBody>
-      </p:sp>
-      <p:sp>
-        <p:nvSpPr>
-          <p:cNvPr id="5" name="Notes Placeholder 4"/>
-          <p:cNvSpPr>
-            <a:spLocks noGrp="1"/>
-          </p:cNvSpPr>
-          <p:nvPr>
-            <p:ph type="body" sz="quarter" idx="3"/>
-          </p:nvPr>
-        </p:nvSpPr>
-        <p:spPr>
-          <a:xfrm>
-            <a:off x="685800" y="4400550"/>
-            <a:ext cx="5486400" cy="3600450"/>
-          </a:xfrm>
-          <a:prstGeom prst="rect">
-            <a:avLst/>
-          </a:prstGeom>
-        </p:spPr>
-        <p:txBody>
-          <a:bodyPr vert="horz" lIns="91440" tIns="45720" rIns="91440" bIns="45720" rtlCol="0"/>
-          <a:lstStyle/>
-          <a:p>
-            <a:pPr lvl="0"/>
-            <a:r>
-              <a:rPr lang="en-US"/>
-              <a:t>Click to edit Master text styles</a:t>
-            </a:r>
-          </a:p>
-          <a:p>
-            <a:pPr lvl="1"/>
-            <a:r>
-              <a:rPr lang="en-US"/>
-              <a:t>Second level</a:t>
-            </a:r>
-          </a:p>
-          <a:p>
-            <a:pPr lvl="2"/>
-            <a:r>
-              <a:rPr lang="en-US"/>
-              <a:t>Third level</a:t>
-            </a:r>
-          </a:p>
-          <a:p>
-            <a:pPr lvl="3"/>
-            <a:r>
-              <a:rPr lang="en-US"/>
-              <a:t>Fourth level</a:t>
-            </a:r>
-          </a:p>
-          <a:p>
-            <a:pPr lvl="4"/>
-            <a:r>
-              <a:rPr lang="en-US"/>
-              <a:t>Fifth level</a:t>
-            </a:r>
-          </a:p>
-        </p:txBody>
-      </p:sp>
-      <p:sp>
-        <p:nvSpPr>
-          <p:cNvPr id="6" name="Footer Placeholder 5"/>
-          <p:cNvSpPr>
-            <a:spLocks noGrp="1"/>
-          </p:cNvSpPr>
-          <p:nvPr>
-            <p:ph type="ftr" sz="quarter" idx="4"/>
-          </p:nvPr>
-        </p:nvSpPr>
-        <p:spPr>
-          <a:xfrm>
-            <a:off x="0" y="8685213"/>
-            <a:ext cx="2971800" cy="458787"/>
-          </a:xfrm>
-          <a:prstGeom prst="rect">
-            <a:avLst/>
-          </a:prstGeom>
-        </p:spPr>
-        <p:txBody>
-          <a:bodyPr vert="horz" lIns="91440" tIns="45720" rIns="91440" bIns="45720" rtlCol="0" anchor="b"/>
-          <a:lstStyle>
-            <a:lvl1pPr algn="l">
-              <a:defRPr sz="1200"/>
-            </a:lvl1pPr>
-          </a:lstStyle>
-          <a:p>
-            <a:endParaRPr lang="en-US"/>
-          </a:p>
-        </p:txBody>
-      </p:sp>
-      <p:sp>
-        <p:nvSpPr>
-          <p:cNvPr id="7" name="Slide Number Placeholder 6"/>
-          <p:cNvSpPr>
-            <a:spLocks noGrp="1"/>
-          </p:cNvSpPr>
-          <p:nvPr>
-            <p:ph type="sldNum" sz="quarter" idx="5"/>
-          </p:nvPr>
-        </p:nvSpPr>
-        <p:spPr>
-          <a:xfrm>
-            <a:off x="3884613" y="8685213"/>
-            <a:ext cx="2971800" cy="458787"/>
-          </a:xfrm>
-          <a:prstGeom prst="rect">
-            <a:avLst/>
-          </a:prstGeom>
-        </p:spPr>
-        <p:txBody>
-          <a:bodyPr vert="horz" lIns="91440" tIns="45720" rIns="91440" bIns="45720" rtlCol="0" anchor="b"/>
-          <a:lstStyle>
-            <a:lvl1pPr algn="r">
-              <a:defRPr sz="1200"/>
-            </a:lvl1pPr>
-          </a:lstStyle>
-          <a:p>
-            <a:fld id="{CE5E9CC1-C706-0F49-92D6-E571CC5EEA8F}" type="slidenum">
-              <a:rPr lang="en-US"/>
-              <a:t>‹#›</a:t>
-            </a:fld>
-            <a:endParaRPr lang="en-US"/>
-          </a:p>
-        </p:txBody>
-      </p:sp>
     </p:spTree>
     <p:extLst>
       <p:ext uri="{BB962C8B-B14F-4D97-AF65-F5344CB8AC3E}">
-        <p14:creationId xmlns:p14="http://schemas.microsoft.com/office/powerpoint/2010/main" val="1024086991"/>
+        <p14:creationId xmlns:p14="http://schemas.microsoft.com/office/powerpoint/2010/main" val="2476604312"/>
       </p:ext>
     </p:extLst>
   </p:cSld>
@@ -852,10 +573,6 @@
           <a:bodyPr/>
           <a:lstStyle/>
           <a:p>
-            <a:r>
-              <a:rPr lang="en-US" dirty="0"/>
-              <a:t/>
-            </a:r>
             <a:endParaRPr lang="en-US" dirty="0"/>
           </a:p>
         </p:txBody>
@@ -940,10 +657,6 @@
           <a:bodyPr/>
           <a:lstStyle/>
           <a:p>
-            <a:r>
-              <a:rPr lang="en-US" dirty="0"/>
-              <a:t/>
-            </a:r>
             <a:endParaRPr lang="en-US" dirty="0"/>
           </a:p>
         </p:txBody>
@@ -1028,10 +741,6 @@
           <a:bodyPr/>
           <a:lstStyle/>
           <a:p>
-            <a:r>
-              <a:rPr lang="en-US" dirty="0"/>
-              <a:t/>
-            </a:r>
             <a:endParaRPr lang="en-US" dirty="0"/>
           </a:p>
         </p:txBody>
@@ -1116,10 +825,6 @@
           <a:bodyPr/>
           <a:lstStyle/>
           <a:p>
-            <a:r>
-              <a:rPr lang="en-US" dirty="0"/>
-              <a:t/>
-            </a:r>
             <a:endParaRPr lang="en-US" dirty="0"/>
           </a:p>
         </p:txBody>
@@ -1204,10 +909,6 @@
           <a:bodyPr/>
           <a:lstStyle/>
           <a:p>
-            <a:r>
-              <a:rPr lang="en-US" dirty="0"/>
-              <a:t/>
-            </a:r>
             <a:endParaRPr lang="en-US" dirty="0"/>
           </a:p>
         </p:txBody>
@@ -1292,10 +993,6 @@
           <a:bodyPr/>
           <a:lstStyle/>
           <a:p>
-            <a:r>
-              <a:rPr lang="en-US" dirty="0"/>
-              <a:t/>
-            </a:r>
             <a:endParaRPr lang="en-US" dirty="0"/>
           </a:p>
         </p:txBody>
@@ -1380,10 +1077,6 @@
           <a:bodyPr/>
           <a:lstStyle/>
           <a:p>
-            <a:r>
-              <a:rPr lang="en-US" dirty="0"/>
-              <a:t/>
-            </a:r>
             <a:endParaRPr lang="en-US" dirty="0"/>
           </a:p>
         </p:txBody>
@@ -1468,10 +1161,6 @@
           <a:bodyPr/>
           <a:lstStyle/>
           <a:p>
-            <a:r>
-              <a:rPr lang="en-US" dirty="0"/>
-              <a:t/>
-            </a:r>
             <a:endParaRPr lang="en-US" dirty="0"/>
           </a:p>
         </p:txBody>
@@ -1556,10 +1245,6 @@
           <a:bodyPr/>
           <a:lstStyle/>
           <a:p>
-            <a:r>
-              <a:rPr lang="en-US" dirty="0"/>
-              <a:t/>
-            </a:r>
             <a:endParaRPr lang="en-US" dirty="0"/>
           </a:p>
         </p:txBody>
@@ -1644,10 +1329,6 @@
           <a:bodyPr/>
           <a:lstStyle/>
           <a:p>
-            <a:r>
-              <a:rPr lang="en-US" dirty="0"/>
-              <a:t/>
-            </a:r>
             <a:endParaRPr lang="en-US" dirty="0"/>
           </a:p>
         </p:txBody>
@@ -1732,10 +1413,6 @@
           <a:bodyPr/>
           <a:lstStyle/>
           <a:p>
-            <a:r>
-              <a:rPr lang="en-US" dirty="0"/>
-              <a:t/>
-            </a:r>
             <a:endParaRPr lang="en-US" dirty="0"/>
           </a:p>
         </p:txBody>
@@ -1809,6 +1486,11 @@
 <file path=ppt/slideMasters/slideMaster1.xml><?xml version="1.0" encoding="utf-8"?>
 <p:sldMaster xmlns:a="http://schemas.openxmlformats.org/drawingml/2006/main" xmlns:r="http://schemas.openxmlformats.org/officeDocument/2006/relationships" xmlns:p="http://schemas.openxmlformats.org/presentationml/2006/main">
   <p:cSld>
+    <p:bg>
+      <p:bgRef idx="1001">
+        <a:schemeClr val="bg1"/>
+      </p:bgRef>
+    </p:bg>
     <p:spTree>
       <p:nvGrpSpPr>
         <p:cNvPr id="1" name=""/>
@@ -2091,6 +1773,7 @@
         <a:solidFill>
           <a:srgbClr val="0B2545"/>
         </a:solidFill>
+        <a:effectLst/>
       </p:bgPr>
     </p:bg>
     <p:spTree>
@@ -2128,7 +1811,7 @@
           <a:bodyPr wrap="square" rtlCol="0" anchor="ctr"/>
           <a:lstStyle/>
           <a:p>
-            <a:pPr indent="0" marL="0">
+            <a:pPr marL="0" indent="0">
               <a:buNone/>
             </a:pPr>
             <a:r>
@@ -2167,7 +1850,7 @@
           <a:bodyPr wrap="square" rtlCol="0" anchor="ctr"/>
           <a:lstStyle/>
           <a:p>
-            <a:pPr indent="0" marL="0">
+            <a:pPr marL="0" indent="0">
               <a:buNone/>
             </a:pPr>
             <a:r>
@@ -2206,7 +1889,7 @@
           <a:bodyPr wrap="square" rtlCol="0" anchor="ctr"/>
           <a:lstStyle/>
           <a:p>
-            <a:pPr indent="0" marL="0">
+            <a:pPr marL="0" indent="0">
               <a:buNone/>
             </a:pPr>
             <a:r>
@@ -2245,7 +1928,7 @@
           <a:bodyPr wrap="square" rtlCol="0" anchor="ctr"/>
           <a:lstStyle/>
           <a:p>
-            <a:pPr indent="0" marL="0">
+            <a:pPr marL="0" indent="0">
               <a:buNone/>
             </a:pPr>
             <a:r>
@@ -2279,6 +1962,58 @@
           </a:solidFill>
           <a:ln/>
         </p:spPr>
+        <p:txBody>
+          <a:bodyPr/>
+          <a:lstStyle/>
+          <a:p>
+            <a:endParaRPr lang="es-AR"/>
+          </a:p>
+        </p:txBody>
+      </p:sp>
+      <p:sp>
+        <p:nvSpPr>
+          <p:cNvPr id="8" name="Text 2">
+            <a:extLst>
+              <a:ext uri="{FF2B5EF4-FFF2-40B4-BE49-F238E27FC236}">
+                <a16:creationId xmlns:a16="http://schemas.microsoft.com/office/drawing/2014/main" id="{18FD62E2-CE3C-72A7-448D-849C47CFF800}"/>
+              </a:ext>
+            </a:extLst>
+          </p:cNvPr>
+          <p:cNvSpPr/>
+          <p:nvPr/>
+        </p:nvSpPr>
+        <p:spPr>
+          <a:xfrm>
+            <a:off x="465908" y="5576284"/>
+            <a:ext cx="10881360" cy="457200"/>
+          </a:xfrm>
+          <a:prstGeom prst="rect">
+            <a:avLst/>
+          </a:prstGeom>
+          <a:noFill/>
+          <a:ln/>
+        </p:spPr>
+        <p:txBody>
+          <a:bodyPr wrap="square" rtlCol="0" anchor="ctr"/>
+          <a:lstStyle/>
+          <a:p>
+            <a:pPr marL="0" indent="0">
+              <a:buNone/>
+            </a:pPr>
+            <a:r>
+              <a:rPr lang="en-US" sz="1400" dirty="0">
+                <a:solidFill>
+                  <a:srgbClr val="9FB3C8"/>
+                </a:solidFill>
+                <a:latin typeface="Arial" pitchFamily="34" charset="0"/>
+                <a:ea typeface="Arial" pitchFamily="34" charset="-122"/>
+                <a:cs typeface="Arial" pitchFamily="34" charset="-120"/>
+              </a:rPr>
+              <a:t>Autores: María Isabel Ledezma Romero, Nicolas Bentancor, Flavia Luisa Crolla, Estanislao Carlos Cairoli</a:t>
+            </a:r>
+            <a:endParaRPr lang="en-US" sz="1400" dirty="0"/>
+          </a:p>
+        </p:txBody>
       </p:sp>
     </p:spTree>
   </p:cSld>
@@ -2296,6 +2031,7 @@
         <a:solidFill>
           <a:srgbClr val="FFFFFF"/>
         </a:solidFill>
+        <a:effectLst/>
       </p:bgPr>
     </p:bg>
     <p:spTree>
@@ -2333,11 +2069,11 @@
           <a:bodyPr wrap="square" rtlCol="0" anchor="ctr"/>
           <a:lstStyle/>
           <a:p>
-            <a:pPr indent="0" marL="0">
+            <a:pPr marL="0" indent="0">
               <a:buNone/>
             </a:pPr>
             <a:r>
-              <a:rPr lang="en-US" sz="1200" b="1" spc="150" kern="0" dirty="0">
+              <a:rPr lang="en-US" sz="1200" b="1" kern="0" spc="150" dirty="0">
                 <a:solidFill>
                   <a:srgbClr val="13A89E"/>
                 </a:solidFill>
@@ -2369,7 +2105,7 @@
           <a:bodyPr wrap="square" rtlCol="0" anchor="ctr"/>
           <a:lstStyle/>
           <a:p>
-            <a:pPr indent="0" marL="0">
+            <a:pPr marL="0" indent="0">
               <a:buNone/>
             </a:pPr>
             <a:r>
@@ -2410,13 +2146,20 @@
             <a:prstDash val="solid"/>
           </a:ln>
           <a:effectLst>
-            <a:outerShdw sx="100000" sy="100000" kx="0" ky="0" algn="bl" rotWithShape="0" blurRad="76200" dist="25400" dir="5400000">
+            <a:outerShdw blurRad="76200" dist="25400" dir="5400000" algn="bl" rotWithShape="0">
               <a:srgbClr val="9AA5B1">
                 <a:alpha val="25000"/>
               </a:srgbClr>
             </a:outerShdw>
           </a:effectLst>
         </p:spPr>
+        <p:txBody>
+          <a:bodyPr/>
+          <a:lstStyle/>
+          <a:p>
+            <a:endParaRPr lang="es-AR"/>
+          </a:p>
+        </p:txBody>
       </p:sp>
       <p:sp>
         <p:nvSpPr>
@@ -2439,7 +2182,7 @@
           <a:bodyPr wrap="square" rtlCol="0" anchor="ctr"/>
           <a:lstStyle/>
           <a:p>
-            <a:pPr indent="0" marL="0">
+            <a:pPr marL="0" indent="0">
               <a:buNone/>
             </a:pPr>
             <a:r>
@@ -2556,13 +2299,20 @@
             <a:prstDash val="solid"/>
           </a:ln>
           <a:effectLst>
-            <a:outerShdw sx="100000" sy="100000" kx="0" ky="0" algn="bl" rotWithShape="0" blurRad="76200" dist="25400" dir="5400000">
+            <a:outerShdw blurRad="76200" dist="25400" dir="5400000" algn="bl" rotWithShape="0">
               <a:srgbClr val="9AA5B1">
                 <a:alpha val="25000"/>
               </a:srgbClr>
             </a:outerShdw>
           </a:effectLst>
         </p:spPr>
+        <p:txBody>
+          <a:bodyPr/>
+          <a:lstStyle/>
+          <a:p>
+            <a:endParaRPr lang="es-AR"/>
+          </a:p>
+        </p:txBody>
       </p:sp>
       <p:sp>
         <p:nvSpPr>
@@ -2585,7 +2335,7 @@
           <a:bodyPr wrap="square" rtlCol="0" anchor="ctr"/>
           <a:lstStyle/>
           <a:p>
-            <a:pPr indent="0" marL="0">
+            <a:pPr marL="0" indent="0">
               <a:buNone/>
             </a:pPr>
             <a:r>
@@ -2692,6 +2442,7 @@
         <a:solidFill>
           <a:srgbClr val="FFFFFF"/>
         </a:solidFill>
+        <a:effectLst/>
       </p:bgPr>
     </p:bg>
     <p:spTree>
@@ -2729,11 +2480,11 @@
           <a:bodyPr wrap="square" rtlCol="0" anchor="ctr"/>
           <a:lstStyle/>
           <a:p>
-            <a:pPr indent="0" marL="0">
+            <a:pPr marL="0" indent="0">
               <a:buNone/>
             </a:pPr>
             <a:r>
-              <a:rPr lang="en-US" sz="1200" b="1" spc="150" kern="0" dirty="0">
+              <a:rPr lang="en-US" sz="1200" b="1" kern="0" spc="150" dirty="0">
                 <a:solidFill>
                   <a:srgbClr val="13A89E"/>
                 </a:solidFill>
@@ -2765,7 +2516,7 @@
           <a:bodyPr wrap="square" rtlCol="0" anchor="ctr"/>
           <a:lstStyle/>
           <a:p>
-            <a:pPr indent="0" marL="0">
+            <a:pPr marL="0" indent="0">
               <a:buNone/>
             </a:pPr>
             <a:r>
@@ -2806,13 +2557,20 @@
             <a:prstDash val="solid"/>
           </a:ln>
           <a:effectLst>
-            <a:outerShdw sx="100000" sy="100000" kx="0" ky="0" algn="bl" rotWithShape="0" blurRad="76200" dist="25400" dir="5400000">
+            <a:outerShdw blurRad="76200" dist="25400" dir="5400000" algn="bl" rotWithShape="0">
               <a:srgbClr val="9AA5B1">
                 <a:alpha val="25000"/>
               </a:srgbClr>
             </a:outerShdw>
           </a:effectLst>
         </p:spPr>
+        <p:txBody>
+          <a:bodyPr/>
+          <a:lstStyle/>
+          <a:p>
+            <a:endParaRPr lang="es-AR"/>
+          </a:p>
+        </p:txBody>
       </p:sp>
       <p:sp>
         <p:nvSpPr>
@@ -2835,7 +2593,7 @@
           <a:bodyPr wrap="square" rtlCol="0" anchor="ctr"/>
           <a:lstStyle/>
           <a:p>
-            <a:pPr indent="0" marL="0">
+            <a:pPr marL="0" indent="0">
               <a:buNone/>
             </a:pPr>
             <a:r>
@@ -2952,13 +2710,20 @@
             <a:prstDash val="solid"/>
           </a:ln>
           <a:effectLst>
-            <a:outerShdw sx="100000" sy="100000" kx="0" ky="0" algn="bl" rotWithShape="0" blurRad="76200" dist="25400" dir="5400000">
+            <a:outerShdw blurRad="76200" dist="25400" dir="5400000" algn="bl" rotWithShape="0">
               <a:srgbClr val="9AA5B1">
                 <a:alpha val="25000"/>
               </a:srgbClr>
             </a:outerShdw>
           </a:effectLst>
         </p:spPr>
+        <p:txBody>
+          <a:bodyPr/>
+          <a:lstStyle/>
+          <a:p>
+            <a:endParaRPr lang="es-AR"/>
+          </a:p>
+        </p:txBody>
       </p:sp>
       <p:sp>
         <p:nvSpPr>
@@ -2981,7 +2746,7 @@
           <a:bodyPr wrap="square" rtlCol="0" anchor="ctr"/>
           <a:lstStyle/>
           <a:p>
-            <a:pPr indent="0" marL="0">
+            <a:pPr marL="0" indent="0">
               <a:buNone/>
             </a:pPr>
             <a:r>
@@ -3088,6 +2853,7 @@
         <a:solidFill>
           <a:srgbClr val="FFFFFF"/>
         </a:solidFill>
+        <a:effectLst/>
       </p:bgPr>
     </p:bg>
     <p:spTree>
@@ -3125,11 +2891,11 @@
           <a:bodyPr wrap="square" rtlCol="0" anchor="ctr"/>
           <a:lstStyle/>
           <a:p>
-            <a:pPr indent="0" marL="0">
+            <a:pPr marL="0" indent="0">
               <a:buNone/>
             </a:pPr>
             <a:r>
-              <a:rPr lang="en-US" sz="1200" b="1" spc="150" kern="0" dirty="0">
+              <a:rPr lang="en-US" sz="1200" b="1" kern="0" spc="150" dirty="0">
                 <a:solidFill>
                   <a:srgbClr val="13A89E"/>
                 </a:solidFill>
@@ -3161,7 +2927,7 @@
           <a:bodyPr wrap="square" rtlCol="0" anchor="ctr"/>
           <a:lstStyle/>
           <a:p>
-            <a:pPr indent="0" marL="0">
+            <a:pPr marL="0" indent="0">
               <a:buNone/>
             </a:pPr>
             <a:r>
@@ -3202,13 +2968,20 @@
             <a:prstDash val="solid"/>
           </a:ln>
           <a:effectLst>
-            <a:outerShdw sx="100000" sy="100000" kx="0" ky="0" algn="bl" rotWithShape="0" blurRad="76200" dist="25400" dir="5400000">
+            <a:outerShdw blurRad="76200" dist="25400" dir="5400000" algn="bl" rotWithShape="0">
               <a:srgbClr val="9AA5B1">
                 <a:alpha val="25000"/>
               </a:srgbClr>
             </a:outerShdw>
           </a:effectLst>
         </p:spPr>
+        <p:txBody>
+          <a:bodyPr/>
+          <a:lstStyle/>
+          <a:p>
+            <a:endParaRPr lang="es-AR"/>
+          </a:p>
+        </p:txBody>
       </p:sp>
       <p:sp>
         <p:nvSpPr>
@@ -3231,7 +3004,7 @@
           <a:bodyPr wrap="square" rtlCol="0" anchor="ctr"/>
           <a:lstStyle/>
           <a:p>
-            <a:pPr indent="0" marL="0">
+            <a:pPr marL="0" indent="0">
               <a:buNone/>
             </a:pPr>
             <a:r>
@@ -3348,13 +3121,20 @@
             <a:prstDash val="solid"/>
           </a:ln>
           <a:effectLst>
-            <a:outerShdw sx="100000" sy="100000" kx="0" ky="0" algn="bl" rotWithShape="0" blurRad="76200" dist="25400" dir="5400000">
+            <a:outerShdw blurRad="76200" dist="25400" dir="5400000" algn="bl" rotWithShape="0">
               <a:srgbClr val="9AA5B1">
                 <a:alpha val="25000"/>
               </a:srgbClr>
             </a:outerShdw>
           </a:effectLst>
         </p:spPr>
+        <p:txBody>
+          <a:bodyPr/>
+          <a:lstStyle/>
+          <a:p>
+            <a:endParaRPr lang="es-AR"/>
+          </a:p>
+        </p:txBody>
       </p:sp>
       <p:sp>
         <p:nvSpPr>
@@ -3377,7 +3157,7 @@
           <a:bodyPr wrap="square" rtlCol="0" anchor="ctr"/>
           <a:lstStyle/>
           <a:p>
-            <a:pPr indent="0" marL="0">
+            <a:pPr marL="0" indent="0">
               <a:buNone/>
             </a:pPr>
             <a:r>
@@ -3484,6 +3264,7 @@
         <a:solidFill>
           <a:srgbClr val="FFFFFF"/>
         </a:solidFill>
+        <a:effectLst/>
       </p:bgPr>
     </p:bg>
     <p:spTree>
@@ -3521,11 +3302,11 @@
           <a:bodyPr wrap="square" rtlCol="0" anchor="ctr"/>
           <a:lstStyle/>
           <a:p>
-            <a:pPr indent="0" marL="0">
+            <a:pPr marL="0" indent="0">
               <a:buNone/>
             </a:pPr>
             <a:r>
-              <a:rPr lang="en-US" sz="1200" b="1" spc="150" kern="0" dirty="0">
+              <a:rPr lang="en-US" sz="1200" b="1" kern="0" spc="150" dirty="0">
                 <a:solidFill>
                   <a:srgbClr val="13A89E"/>
                 </a:solidFill>
@@ -3557,7 +3338,7 @@
           <a:bodyPr wrap="square" rtlCol="0" anchor="ctr"/>
           <a:lstStyle/>
           <a:p>
-            <a:pPr indent="0" marL="0">
+            <a:pPr marL="0" indent="0">
               <a:buNone/>
             </a:pPr>
             <a:r>
@@ -3598,13 +3379,20 @@
             <a:prstDash val="solid"/>
           </a:ln>
           <a:effectLst>
-            <a:outerShdw sx="100000" sy="100000" kx="0" ky="0" algn="bl" rotWithShape="0" blurRad="76200" dist="25400" dir="5400000">
+            <a:outerShdw blurRad="76200" dist="25400" dir="5400000" algn="bl" rotWithShape="0">
               <a:srgbClr val="9AA5B1">
                 <a:alpha val="25000"/>
               </a:srgbClr>
             </a:outerShdw>
           </a:effectLst>
         </p:spPr>
+        <p:txBody>
+          <a:bodyPr/>
+          <a:lstStyle/>
+          <a:p>
+            <a:endParaRPr lang="es-AR"/>
+          </a:p>
+        </p:txBody>
       </p:sp>
       <p:sp>
         <p:nvSpPr>
@@ -3627,7 +3415,7 @@
           <a:bodyPr wrap="square" rtlCol="0" anchor="ctr"/>
           <a:lstStyle/>
           <a:p>
-            <a:pPr indent="0" marL="0">
+            <a:pPr marL="0" indent="0">
               <a:buNone/>
             </a:pPr>
             <a:r>
@@ -3744,13 +3532,20 @@
             <a:prstDash val="solid"/>
           </a:ln>
           <a:effectLst>
-            <a:outerShdw sx="100000" sy="100000" kx="0" ky="0" algn="bl" rotWithShape="0" blurRad="76200" dist="25400" dir="5400000">
+            <a:outerShdw blurRad="76200" dist="25400" dir="5400000" algn="bl" rotWithShape="0">
               <a:srgbClr val="9AA5B1">
                 <a:alpha val="25000"/>
               </a:srgbClr>
             </a:outerShdw>
           </a:effectLst>
         </p:spPr>
+        <p:txBody>
+          <a:bodyPr/>
+          <a:lstStyle/>
+          <a:p>
+            <a:endParaRPr lang="es-AR"/>
+          </a:p>
+        </p:txBody>
       </p:sp>
       <p:sp>
         <p:nvSpPr>
@@ -3773,7 +3568,7 @@
           <a:bodyPr wrap="square" rtlCol="0" anchor="ctr"/>
           <a:lstStyle/>
           <a:p>
-            <a:pPr indent="0" marL="0">
+            <a:pPr marL="0" indent="0">
               <a:buNone/>
             </a:pPr>
             <a:r>
@@ -3908,13 +3703,20 @@
             <a:prstDash val="solid"/>
           </a:ln>
           <a:effectLst>
-            <a:outerShdw sx="100000" sy="100000" kx="0" ky="0" algn="bl" rotWithShape="0" blurRad="76200" dist="25400" dir="5400000">
+            <a:outerShdw blurRad="76200" dist="25400" dir="5400000" algn="bl" rotWithShape="0">
               <a:srgbClr val="9AA5B1">
                 <a:alpha val="25000"/>
               </a:srgbClr>
             </a:outerShdw>
           </a:effectLst>
         </p:spPr>
+        <p:txBody>
+          <a:bodyPr/>
+          <a:lstStyle/>
+          <a:p>
+            <a:endParaRPr lang="es-AR"/>
+          </a:p>
+        </p:txBody>
       </p:sp>
       <p:sp>
         <p:nvSpPr>
@@ -3937,7 +3739,7 @@
           <a:bodyPr wrap="square" rtlCol="0" anchor="ctr"/>
           <a:lstStyle/>
           <a:p>
-            <a:pPr indent="0" marL="0">
+            <a:pPr marL="0" indent="0">
               <a:buNone/>
             </a:pPr>
             <a:r>
@@ -4062,6 +3864,7 @@
         <a:solidFill>
           <a:srgbClr val="13A89E"/>
         </a:solidFill>
+        <a:effectLst/>
       </p:bgPr>
     </p:bg>
     <p:spTree>
@@ -4099,11 +3902,11 @@
           <a:bodyPr wrap="square" rtlCol="0" anchor="ctr"/>
           <a:lstStyle/>
           <a:p>
-            <a:pPr indent="0" marL="0">
+            <a:pPr marL="0" indent="0">
               <a:buNone/>
             </a:pPr>
             <a:r>
-              <a:rPr lang="en-US" sz="1600" b="1" spc="200" kern="0" dirty="0">
+              <a:rPr lang="en-US" sz="1600" b="1" kern="0" spc="200" dirty="0">
                 <a:solidFill>
                   <a:srgbClr val="0B2545"/>
                 </a:solidFill>
@@ -4135,7 +3938,7 @@
           <a:bodyPr wrap="square" rtlCol="0" anchor="ctr"/>
           <a:lstStyle/>
           <a:p>
-            <a:pPr indent="0" marL="0">
+            <a:pPr marL="0" indent="0">
               <a:buNone/>
             </a:pPr>
             <a:r>
@@ -4166,6 +3969,7 @@
         <a:solidFill>
           <a:srgbClr val="FFFFFF"/>
         </a:solidFill>
+        <a:effectLst/>
       </p:bgPr>
     </p:bg>
     <p:spTree>
@@ -4203,11 +4007,11 @@
           <a:bodyPr wrap="square" rtlCol="0" anchor="ctr"/>
           <a:lstStyle/>
           <a:p>
-            <a:pPr indent="0" marL="0">
+            <a:pPr marL="0" indent="0">
               <a:buNone/>
             </a:pPr>
             <a:r>
-              <a:rPr lang="en-US" sz="1200" b="1" spc="150" kern="0" dirty="0">
+              <a:rPr lang="en-US" sz="1200" b="1" kern="0" spc="150" dirty="0">
                 <a:solidFill>
                   <a:srgbClr val="13A89E"/>
                 </a:solidFill>
@@ -4239,7 +4043,7 @@
           <a:bodyPr wrap="square" rtlCol="0" anchor="ctr"/>
           <a:lstStyle/>
           <a:p>
-            <a:pPr indent="0" marL="0">
+            <a:pPr marL="0" indent="0">
               <a:buNone/>
             </a:pPr>
             <a:r>
@@ -4256,14 +4060,14 @@
       </p:sp>
       <p:pic>
         <p:nvPicPr>
-          <p:cNvPr id="4" name="Image 0" descr="/home/claude/LMD-final/LMD-master/reports/architecture_diagram.png">    </p:cNvPr>
+          <p:cNvPr id="4" name="Image 0" descr="/home/claude/LMD-final/LMD-master/reports/architecture_diagram.png"/>
           <p:cNvPicPr>
             <a:picLocks noChangeAspect="1"/>
           </p:cNvPicPr>
           <p:nvPr/>
         </p:nvPicPr>
         <p:blipFill>
-          <a:blip r:embed="rId1"/>
+          <a:blip r:embed="rId3"/>
           <a:stretch>
             <a:fillRect/>
           </a:stretch>
@@ -4294,6 +4098,7 @@
         <a:solidFill>
           <a:srgbClr val="FFFFFF"/>
         </a:solidFill>
+        <a:effectLst/>
       </p:bgPr>
     </p:bg>
     <p:spTree>
@@ -4331,11 +4136,11 @@
           <a:bodyPr wrap="square" rtlCol="0" anchor="ctr"/>
           <a:lstStyle/>
           <a:p>
-            <a:pPr indent="0" marL="0">
+            <a:pPr marL="0" indent="0">
               <a:buNone/>
             </a:pPr>
             <a:r>
-              <a:rPr lang="en-US" sz="1200" b="1" spc="150" kern="0" dirty="0">
+              <a:rPr lang="en-US" sz="1200" b="1" kern="0" spc="150" dirty="0">
                 <a:solidFill>
                   <a:srgbClr val="13A89E"/>
                 </a:solidFill>
@@ -4367,7 +4172,7 @@
           <a:bodyPr wrap="square" rtlCol="0" anchor="ctr"/>
           <a:lstStyle/>
           <a:p>
-            <a:pPr indent="0" marL="0">
+            <a:pPr marL="0" indent="0">
               <a:buNone/>
             </a:pPr>
             <a:r>
@@ -4408,13 +4213,20 @@
             <a:prstDash val="solid"/>
           </a:ln>
           <a:effectLst>
-            <a:outerShdw sx="100000" sy="100000" kx="0" ky="0" algn="bl" rotWithShape="0" blurRad="76200" dist="25400" dir="5400000">
+            <a:outerShdw blurRad="76200" dist="25400" dir="5400000" algn="bl" rotWithShape="0">
               <a:srgbClr val="9AA5B1">
                 <a:alpha val="25000"/>
               </a:srgbClr>
             </a:outerShdw>
           </a:effectLst>
         </p:spPr>
+        <p:txBody>
+          <a:bodyPr/>
+          <a:lstStyle/>
+          <a:p>
+            <a:endParaRPr lang="es-AR"/>
+          </a:p>
+        </p:txBody>
       </p:sp>
       <p:sp>
         <p:nvSpPr>
@@ -4437,7 +4249,7 @@
           <a:bodyPr wrap="square" rtlCol="0" anchor="ctr"/>
           <a:lstStyle/>
           <a:p>
-            <a:pPr indent="0" marL="0">
+            <a:pPr marL="0" indent="0">
               <a:buNone/>
             </a:pPr>
             <a:r>
@@ -4572,13 +4384,20 @@
             <a:prstDash val="solid"/>
           </a:ln>
           <a:effectLst>
-            <a:outerShdw sx="100000" sy="100000" kx="0" ky="0" algn="bl" rotWithShape="0" blurRad="76200" dist="25400" dir="5400000">
+            <a:outerShdw blurRad="76200" dist="25400" dir="5400000" algn="bl" rotWithShape="0">
               <a:srgbClr val="9AA5B1">
                 <a:alpha val="25000"/>
               </a:srgbClr>
             </a:outerShdw>
           </a:effectLst>
         </p:spPr>
+        <p:txBody>
+          <a:bodyPr/>
+          <a:lstStyle/>
+          <a:p>
+            <a:endParaRPr lang="es-AR"/>
+          </a:p>
+        </p:txBody>
       </p:sp>
       <p:sp>
         <p:nvSpPr>
@@ -4601,7 +4420,7 @@
           <a:bodyPr wrap="square" rtlCol="0" anchor="ctr"/>
           <a:lstStyle/>
           <a:p>
-            <a:pPr indent="0" marL="0">
+            <a:pPr marL="0" indent="0">
               <a:buNone/>
             </a:pPr>
             <a:r>
@@ -4726,6 +4545,7 @@
         <a:solidFill>
           <a:srgbClr val="13A89E"/>
         </a:solidFill>
+        <a:effectLst/>
       </p:bgPr>
     </p:bg>
     <p:spTree>
@@ -4763,11 +4583,11 @@
           <a:bodyPr wrap="square" rtlCol="0" anchor="ctr"/>
           <a:lstStyle/>
           <a:p>
-            <a:pPr indent="0" marL="0">
+            <a:pPr marL="0" indent="0">
               <a:buNone/>
             </a:pPr>
             <a:r>
-              <a:rPr lang="en-US" sz="1600" b="1" spc="200" kern="0" dirty="0">
+              <a:rPr lang="en-US" sz="1600" b="1" kern="0" spc="200" dirty="0">
                 <a:solidFill>
                   <a:srgbClr val="0B2545"/>
                 </a:solidFill>
@@ -4799,7 +4619,7 @@
           <a:bodyPr wrap="square" rtlCol="0" anchor="ctr"/>
           <a:lstStyle/>
           <a:p>
-            <a:pPr indent="0" marL="0">
+            <a:pPr marL="0" indent="0">
               <a:buNone/>
             </a:pPr>
             <a:r>
@@ -4830,6 +4650,7 @@
         <a:solidFill>
           <a:srgbClr val="FFFFFF"/>
         </a:solidFill>
+        <a:effectLst/>
       </p:bgPr>
     </p:bg>
     <p:spTree>
@@ -4867,11 +4688,11 @@
           <a:bodyPr wrap="square" rtlCol="0" anchor="ctr"/>
           <a:lstStyle/>
           <a:p>
-            <a:pPr indent="0" marL="0">
+            <a:pPr marL="0" indent="0">
               <a:buNone/>
             </a:pPr>
             <a:r>
-              <a:rPr lang="en-US" sz="1200" b="1" spc="150" kern="0" dirty="0">
+              <a:rPr lang="en-US" sz="1200" b="1" kern="0" spc="150" dirty="0">
                 <a:solidFill>
                   <a:srgbClr val="13A89E"/>
                 </a:solidFill>
@@ -4903,7 +4724,7 @@
           <a:bodyPr wrap="square" rtlCol="0" anchor="ctr"/>
           <a:lstStyle/>
           <a:p>
-            <a:pPr indent="0" marL="0">
+            <a:pPr marL="0" indent="0">
               <a:buNone/>
             </a:pPr>
             <a:r>
@@ -4944,13 +4765,20 @@
             <a:prstDash val="solid"/>
           </a:ln>
           <a:effectLst>
-            <a:outerShdw sx="100000" sy="100000" kx="0" ky="0" algn="bl" rotWithShape="0" blurRad="76200" dist="25400" dir="5400000">
+            <a:outerShdw blurRad="76200" dist="25400" dir="5400000" algn="bl" rotWithShape="0">
               <a:srgbClr val="9AA5B1">
                 <a:alpha val="25000"/>
               </a:srgbClr>
             </a:outerShdw>
           </a:effectLst>
         </p:spPr>
+        <p:txBody>
+          <a:bodyPr/>
+          <a:lstStyle/>
+          <a:p>
+            <a:endParaRPr lang="es-AR"/>
+          </a:p>
+        </p:txBody>
       </p:sp>
       <p:sp>
         <p:nvSpPr>
@@ -4973,7 +4801,7 @@
           <a:bodyPr wrap="square" rtlCol="0" anchor="ctr"/>
           <a:lstStyle/>
           <a:p>
-            <a:pPr indent="0" marL="0">
+            <a:pPr marL="0" indent="0">
               <a:buNone/>
             </a:pPr>
             <a:r>
@@ -5090,13 +4918,20 @@
             <a:prstDash val="solid"/>
           </a:ln>
           <a:effectLst>
-            <a:outerShdw sx="100000" sy="100000" kx="0" ky="0" algn="bl" rotWithShape="0" blurRad="76200" dist="25400" dir="5400000">
+            <a:outerShdw blurRad="76200" dist="25400" dir="5400000" algn="bl" rotWithShape="0">
               <a:srgbClr val="9AA5B1">
                 <a:alpha val="25000"/>
               </a:srgbClr>
             </a:outerShdw>
           </a:effectLst>
         </p:spPr>
+        <p:txBody>
+          <a:bodyPr/>
+          <a:lstStyle/>
+          <a:p>
+            <a:endParaRPr lang="es-AR"/>
+          </a:p>
+        </p:txBody>
       </p:sp>
       <p:sp>
         <p:nvSpPr>
@@ -5119,7 +4954,7 @@
           <a:bodyPr wrap="square" rtlCol="0" anchor="ctr"/>
           <a:lstStyle/>
           <a:p>
-            <a:pPr indent="0" marL="0">
+            <a:pPr marL="0" indent="0">
               <a:buNone/>
             </a:pPr>
             <a:r>
@@ -5262,6 +5097,7 @@
         <a:solidFill>
           <a:srgbClr val="FFFFFF"/>
         </a:solidFill>
+        <a:effectLst/>
       </p:bgPr>
     </p:bg>
     <p:spTree>
@@ -5299,11 +5135,11 @@
           <a:bodyPr wrap="square" rtlCol="0" anchor="ctr"/>
           <a:lstStyle/>
           <a:p>
-            <a:pPr indent="0" marL="0">
+            <a:pPr marL="0" indent="0">
               <a:buNone/>
             </a:pPr>
             <a:r>
-              <a:rPr lang="en-US" sz="1200" b="1" spc="150" kern="0" dirty="0">
+              <a:rPr lang="en-US" sz="1200" b="1" kern="0" spc="150" dirty="0">
                 <a:solidFill>
                   <a:srgbClr val="13A89E"/>
                 </a:solidFill>
@@ -5335,7 +5171,7 @@
           <a:bodyPr wrap="square" rtlCol="0" anchor="ctr"/>
           <a:lstStyle/>
           <a:p>
-            <a:pPr indent="0" marL="0">
+            <a:pPr marL="0" indent="0">
               <a:buNone/>
             </a:pPr>
             <a:r>
@@ -5371,7 +5207,7 @@
           <a:bodyPr wrap="square" rtlCol="0" anchor="ctr"/>
           <a:lstStyle/>
           <a:p>
-            <a:pPr indent="0" marL="0">
+            <a:pPr marL="0" indent="0">
               <a:buNone/>
             </a:pPr>
             <a:r>
@@ -5388,7 +5224,7 @@
       </p:sp>
       <p:graphicFrame>
         <p:nvGraphicFramePr>
-          <p:cNvPr id="5" name="Chart 0" descr=""/>
+          <p:cNvPr id="5" name="Chart 0"/>
           <p:cNvGraphicFramePr/>
           <p:nvPr/>
         </p:nvGraphicFramePr>
@@ -5396,9 +5232,9 @@
           <a:off x="548640" y="1737360"/>
           <a:ext cx="6766560" cy="4389120"/>
         </p:xfrm>
-        <a:graphic xmlns:a="http://schemas.openxmlformats.org/drawingml/2006/main">
+        <a:graphic>
           <a:graphicData uri="http://schemas.openxmlformats.org/drawingml/2006/chart">
-            <c:chart xmlns:c="http://schemas.openxmlformats.org/drawingml/2006/chart" r:id="rId1"/>
+            <c:chart xmlns:c="http://schemas.openxmlformats.org/drawingml/2006/chart" xmlns:r="http://schemas.openxmlformats.org/officeDocument/2006/relationships" r:id="rId3"/>
           </a:graphicData>
         </a:graphic>
       </p:graphicFrame>
@@ -5428,13 +5264,20 @@
             <a:prstDash val="solid"/>
           </a:ln>
           <a:effectLst>
-            <a:outerShdw sx="100000" sy="100000" kx="0" ky="0" algn="bl" rotWithShape="0" blurRad="76200" dist="25400" dir="5400000">
+            <a:outerShdw blurRad="76200" dist="25400" dir="5400000" algn="bl" rotWithShape="0">
               <a:srgbClr val="9AA5B1">
                 <a:alpha val="25000"/>
               </a:srgbClr>
             </a:outerShdw>
           </a:effectLst>
         </p:spPr>
+        <p:txBody>
+          <a:bodyPr/>
+          <a:lstStyle/>
+          <a:p>
+            <a:endParaRPr lang="es-AR"/>
+          </a:p>
+        </p:txBody>
       </p:sp>
       <p:sp>
         <p:nvSpPr>
@@ -5457,7 +5300,7 @@
           <a:bodyPr wrap="square" rtlCol="0" anchor="ctr"/>
           <a:lstStyle/>
           <a:p>
-            <a:pPr indent="0" marL="0">
+            <a:pPr marL="0" indent="0">
               <a:buNone/>
             </a:pPr>
             <a:r>
@@ -5849,4 +5692,319 @@
     </a:ext>
   </a:extLst>
 </a:theme>
+</file>
+
+<file path=ppt/theme/theme2.xml><?xml version="1.0" encoding="utf-8"?>
+<a:theme xmlns:a="http://schemas.openxmlformats.org/drawingml/2006/main" name="Tema de Office">
+  <a:themeElements>
+    <a:clrScheme name="Office">
+      <a:dk1>
+        <a:sysClr val="windowText" lastClr="000000"/>
+      </a:dk1>
+      <a:lt1>
+        <a:sysClr val="window" lastClr="FFFFFF"/>
+      </a:lt1>
+      <a:dk2>
+        <a:srgbClr val="0E2841"/>
+      </a:dk2>
+      <a:lt2>
+        <a:srgbClr val="E8E8E8"/>
+      </a:lt2>
+      <a:accent1>
+        <a:srgbClr val="156082"/>
+      </a:accent1>
+      <a:accent2>
+        <a:srgbClr val="E97132"/>
+      </a:accent2>
+      <a:accent3>
+        <a:srgbClr val="196B24"/>
+      </a:accent3>
+      <a:accent4>
+        <a:srgbClr val="0F9ED5"/>
+      </a:accent4>
+      <a:accent5>
+        <a:srgbClr val="A02B93"/>
+      </a:accent5>
+      <a:accent6>
+        <a:srgbClr val="4EA72E"/>
+      </a:accent6>
+      <a:hlink>
+        <a:srgbClr val="467886"/>
+      </a:hlink>
+      <a:folHlink>
+        <a:srgbClr val="96607D"/>
+      </a:folHlink>
+    </a:clrScheme>
+    <a:fontScheme name="Office">
+      <a:majorFont>
+        <a:latin typeface="Aptos Display" panose="02110004020202020204"/>
+        <a:ea typeface=""/>
+        <a:cs typeface=""/>
+        <a:font script="Jpan" typeface="游ゴシック Light"/>
+        <a:font script="Hang" typeface="맑은 고딕"/>
+        <a:font script="Hans" typeface="等线 Light"/>
+        <a:font script="Hant" typeface="新細明體"/>
+        <a:font script="Arab" typeface="Times New Roman"/>
+        <a:font script="Hebr" typeface="Times New Roman"/>
+        <a:font script="Thai" typeface="Angsana New"/>
+        <a:font script="Ethi" typeface="Nyala"/>
+        <a:font script="Beng" typeface="Vrinda"/>
+        <a:font script="Gujr" typeface="Shruti"/>
+        <a:font script="Khmr" typeface="MoolBoran"/>
+        <a:font script="Knda" typeface="Tunga"/>
+        <a:font script="Guru" typeface="Raavi"/>
+        <a:font script="Cans" typeface="Euphemia"/>
+        <a:font script="Cher" typeface="Plantagenet Cherokee"/>
+        <a:font script="Yiii" typeface="Microsoft Yi Baiti"/>
+        <a:font script="Tibt" typeface="Microsoft Himalaya"/>
+        <a:font script="Thaa" typeface="MV Boli"/>
+        <a:font script="Deva" typeface="Mangal"/>
+        <a:font script="Telu" typeface="Gautami"/>
+        <a:font script="Taml" typeface="Latha"/>
+        <a:font script="Syrc" typeface="Estrangelo Edessa"/>
+        <a:font script="Orya" typeface="Kalinga"/>
+        <a:font script="Mlym" typeface="Kartika"/>
+        <a:font script="Laoo" typeface="DokChampa"/>
+        <a:font script="Sinh" typeface="Iskoola Pota"/>
+        <a:font script="Mong" typeface="Mongolian Baiti"/>
+        <a:font script="Viet" typeface="Times New Roman"/>
+        <a:font script="Uigh" typeface="Microsoft Uighur"/>
+        <a:font script="Geor" typeface="Sylfaen"/>
+        <a:font script="Armn" typeface="Arial"/>
+        <a:font script="Bugi" typeface="Leelawadee UI"/>
+        <a:font script="Bopo" typeface="Microsoft JhengHei"/>
+        <a:font script="Java" typeface="Javanese Text"/>
+        <a:font script="Lisu" typeface="Segoe UI"/>
+        <a:font script="Mymr" typeface="Myanmar Text"/>
+        <a:font script="Nkoo" typeface="Ebrima"/>
+        <a:font script="Olck" typeface="Nirmala UI"/>
+        <a:font script="Osma" typeface="Ebrima"/>
+        <a:font script="Phag" typeface="Phagspa"/>
+        <a:font script="Syrn" typeface="Estrangelo Edessa"/>
+        <a:font script="Syrj" typeface="Estrangelo Edessa"/>
+        <a:font script="Syre" typeface="Estrangelo Edessa"/>
+        <a:font script="Sora" typeface="Nirmala UI"/>
+        <a:font script="Tale" typeface="Microsoft Tai Le"/>
+        <a:font script="Talu" typeface="Microsoft New Tai Lue"/>
+        <a:font script="Tfng" typeface="Ebrima"/>
+      </a:majorFont>
+      <a:minorFont>
+        <a:latin typeface="Aptos" panose="02110004020202020204"/>
+        <a:ea typeface=""/>
+        <a:cs typeface=""/>
+        <a:font script="Jpan" typeface="游ゴシック"/>
+        <a:font script="Hang" typeface="맑은 고딕"/>
+        <a:font script="Hans" typeface="等线"/>
+        <a:font script="Hant" typeface="新細明體"/>
+        <a:font script="Arab" typeface="Arial"/>
+        <a:font script="Hebr" typeface="Arial"/>
+        <a:font script="Thai" typeface="Cordia New"/>
+        <a:font script="Ethi" typeface="Nyala"/>
+        <a:font script="Beng" typeface="Vrinda"/>
+        <a:font script="Gujr" typeface="Shruti"/>
+        <a:font script="Khmr" typeface="DaunPenh"/>
+        <a:font script="Knda" typeface="Tunga"/>
+        <a:font script="Guru" typeface="Raavi"/>
+        <a:font script="Cans" typeface="Euphemia"/>
+        <a:font script="Cher" typeface="Plantagenet Cherokee"/>
+        <a:font script="Yiii" typeface="Microsoft Yi Baiti"/>
+        <a:font script="Tibt" typeface="Microsoft Himalaya"/>
+        <a:font script="Thaa" typeface="MV Boli"/>
+        <a:font script="Deva" typeface="Mangal"/>
+        <a:font script="Telu" typeface="Gautami"/>
+        <a:font script="Taml" typeface="Latha"/>
+        <a:font script="Syrc" typeface="Estrangelo Edessa"/>
+        <a:font script="Orya" typeface="Kalinga"/>
+        <a:font script="Mlym" typeface="Kartika"/>
+        <a:font script="Laoo" typeface="DokChampa"/>
+        <a:font script="Sinh" typeface="Iskoola Pota"/>
+        <a:font script="Mong" typeface="Mongolian Baiti"/>
+        <a:font script="Viet" typeface="Arial"/>
+        <a:font script="Uigh" typeface="Microsoft Uighur"/>
+        <a:font script="Geor" typeface="Sylfaen"/>
+        <a:font script="Armn" typeface="Arial"/>
+        <a:font script="Bugi" typeface="Leelawadee UI"/>
+        <a:font script="Bopo" typeface="Microsoft JhengHei"/>
+        <a:font script="Java" typeface="Javanese Text"/>
+        <a:font script="Lisu" typeface="Segoe UI"/>
+        <a:font script="Mymr" typeface="Myanmar Text"/>
+        <a:font script="Nkoo" typeface="Ebrima"/>
+        <a:font script="Olck" typeface="Nirmala UI"/>
+        <a:font script="Osma" typeface="Ebrima"/>
+        <a:font script="Phag" typeface="Phagspa"/>
+        <a:font script="Syrn" typeface="Estrangelo Edessa"/>
+        <a:font script="Syrj" typeface="Estrangelo Edessa"/>
+        <a:font script="Syre" typeface="Estrangelo Edessa"/>
+        <a:font script="Sora" typeface="Nirmala UI"/>
+        <a:font script="Tale" typeface="Microsoft Tai Le"/>
+        <a:font script="Talu" typeface="Microsoft New Tai Lue"/>
+        <a:font script="Tfng" typeface="Ebrima"/>
+      </a:minorFont>
+    </a:fontScheme>
+    <a:fmtScheme name="Office">
+      <a:fillStyleLst>
+        <a:solidFill>
+          <a:schemeClr val="phClr"/>
+        </a:solidFill>
+        <a:gradFill rotWithShape="1">
+          <a:gsLst>
+            <a:gs pos="0">
+              <a:schemeClr val="phClr">
+                <a:lumMod val="110000"/>
+                <a:satMod val="105000"/>
+                <a:tint val="67000"/>
+              </a:schemeClr>
+            </a:gs>
+            <a:gs pos="50000">
+              <a:schemeClr val="phClr">
+                <a:lumMod val="105000"/>
+                <a:satMod val="103000"/>
+                <a:tint val="73000"/>
+              </a:schemeClr>
+            </a:gs>
+            <a:gs pos="100000">
+              <a:schemeClr val="phClr">
+                <a:lumMod val="105000"/>
+                <a:satMod val="109000"/>
+                <a:tint val="81000"/>
+              </a:schemeClr>
+            </a:gs>
+          </a:gsLst>
+          <a:lin ang="5400000" scaled="0"/>
+        </a:gradFill>
+        <a:gradFill rotWithShape="1">
+          <a:gsLst>
+            <a:gs pos="0">
+              <a:schemeClr val="phClr">
+                <a:satMod val="103000"/>
+                <a:lumMod val="102000"/>
+                <a:tint val="94000"/>
+              </a:schemeClr>
+            </a:gs>
+            <a:gs pos="50000">
+              <a:schemeClr val="phClr">
+                <a:satMod val="110000"/>
+                <a:lumMod val="100000"/>
+                <a:shade val="100000"/>
+              </a:schemeClr>
+            </a:gs>
+            <a:gs pos="100000">
+              <a:schemeClr val="phClr">
+                <a:lumMod val="99000"/>
+                <a:satMod val="120000"/>
+                <a:shade val="78000"/>
+              </a:schemeClr>
+            </a:gs>
+          </a:gsLst>
+          <a:lin ang="5400000" scaled="0"/>
+        </a:gradFill>
+      </a:fillStyleLst>
+      <a:lnStyleLst>
+        <a:ln w="12700" cap="flat" cmpd="sng" algn="ctr">
+          <a:solidFill>
+            <a:schemeClr val="phClr"/>
+          </a:solidFill>
+          <a:prstDash val="solid"/>
+          <a:miter lim="800000"/>
+        </a:ln>
+        <a:ln w="19050" cap="flat" cmpd="sng" algn="ctr">
+          <a:solidFill>
+            <a:schemeClr val="phClr"/>
+          </a:solidFill>
+          <a:prstDash val="solid"/>
+          <a:miter lim="800000"/>
+        </a:ln>
+        <a:ln w="25400" cap="flat" cmpd="sng" algn="ctr">
+          <a:solidFill>
+            <a:schemeClr val="phClr"/>
+          </a:solidFill>
+          <a:prstDash val="solid"/>
+          <a:miter lim="800000"/>
+        </a:ln>
+      </a:lnStyleLst>
+      <a:effectStyleLst>
+        <a:effectStyle>
+          <a:effectLst/>
+        </a:effectStyle>
+        <a:effectStyle>
+          <a:effectLst/>
+        </a:effectStyle>
+        <a:effectStyle>
+          <a:effectLst>
+            <a:outerShdw blurRad="57150" dist="19050" dir="5400000" algn="ctr" rotWithShape="0">
+              <a:srgbClr val="000000">
+                <a:alpha val="63000"/>
+              </a:srgbClr>
+            </a:outerShdw>
+          </a:effectLst>
+        </a:effectStyle>
+      </a:effectStyleLst>
+      <a:bgFillStyleLst>
+        <a:solidFill>
+          <a:schemeClr val="phClr"/>
+        </a:solidFill>
+        <a:solidFill>
+          <a:schemeClr val="phClr">
+            <a:tint val="95000"/>
+            <a:satMod val="170000"/>
+          </a:schemeClr>
+        </a:solidFill>
+        <a:gradFill rotWithShape="1">
+          <a:gsLst>
+            <a:gs pos="0">
+              <a:schemeClr val="phClr">
+                <a:tint val="93000"/>
+                <a:satMod val="150000"/>
+                <a:shade val="98000"/>
+                <a:lumMod val="102000"/>
+              </a:schemeClr>
+            </a:gs>
+            <a:gs pos="50000">
+              <a:schemeClr val="phClr">
+                <a:tint val="98000"/>
+                <a:satMod val="130000"/>
+                <a:shade val="90000"/>
+                <a:lumMod val="103000"/>
+              </a:schemeClr>
+            </a:gs>
+            <a:gs pos="100000">
+              <a:schemeClr val="phClr">
+                <a:shade val="63000"/>
+                <a:satMod val="120000"/>
+              </a:schemeClr>
+            </a:gs>
+          </a:gsLst>
+          <a:lin ang="5400000" scaled="0"/>
+        </a:gradFill>
+      </a:bgFillStyleLst>
+    </a:fmtScheme>
+  </a:themeElements>
+  <a:objectDefaults>
+    <a:lnDef>
+      <a:spPr/>
+      <a:bodyPr/>
+      <a:lstStyle/>
+      <a:style>
+        <a:lnRef idx="2">
+          <a:schemeClr val="accent1"/>
+        </a:lnRef>
+        <a:fillRef idx="0">
+          <a:schemeClr val="accent1"/>
+        </a:fillRef>
+        <a:effectRef idx="1">
+          <a:schemeClr val="accent1"/>
+        </a:effectRef>
+        <a:fontRef idx="minor">
+          <a:schemeClr val="tx1"/>
+        </a:fontRef>
+      </a:style>
+    </a:lnDef>
+  </a:objectDefaults>
+  <a:extraClrSchemeLst/>
+  <a:extLst>
+    <a:ext uri="{05A4C25C-085E-4340-85A3-A5531E510DB2}">
+      <thm15:themeFamily xmlns:thm15="http://schemas.microsoft.com/office/thememl/2012/main" name="Office Theme" id="{2E142A2C-CD16-42D6-873A-C26D2A0506FA}" vid="{1BDDFF52-6CD6-40A5-AB3C-68EB2F1E4D0A}"/>
+    </a:ext>
+  </a:extLst>
+</a:theme>
 </file>
</xml_diff>